<commit_message>
NUCLEON v1.6: rename :decayMode, :decayProduct and :radiationType
The object properties become :hasDecayMode, :hasDecayProduct and
:hasRadiationType, so no property shares a name with a class
(:decayMode vs :DecayMode). Labels, queries, scripts, Figure 1 and the
documentation follow. No values changed; validate.py and Pellet give
the same results as for v1.5.

Co-Authored-By: Claude Opus 5.5 <noreply@anthropic.com>
Claude-Session: https://claude.ai/code/session_01U6xhbV6sCj4eYhbFMowS9Y
</commit_message>
<xml_diff>
--- a/docs/figures/class_figure.pptx
+++ b/docs/figures/class_figure.pptx
@@ -4809,7 +4809,7 @@
                   <a:srgbClr val="C00000"/>
                 </a:solidFill>
               </a:rPr>
-              <a:t>:radiationType</a:t>
+              <a:t>:hasRadiationType</a:t>
             </a:r>
           </a:p>
         </p:txBody>
@@ -4953,7 +4953,7 @@
                   <a:srgbClr val="C00000"/>
                 </a:solidFill>
               </a:rPr>
-              <a:t>:decayProduct</a:t>
+              <a:t>:hasDecayProduct</a:t>
             </a:r>
           </a:p>
         </p:txBody>
@@ -5025,7 +5025,7 @@
                   <a:srgbClr val="C00000"/>
                 </a:solidFill>
               </a:rPr>
-              <a:t>:decayMode</a:t>
+              <a:t>:hasDecayMode</a:t>
             </a:r>
           </a:p>
         </p:txBody>

</xml_diff>